<commit_message>
Publicare 2026-10-08 (versiuni: 2026.1.0, 2026.1.1)
</commit_message>
<xml_diff>
--- a/SPM_MGVI/fr/fisiere/C02.pptx
+++ b/SPM_MGVI/fr/fisiere/C02.pptx
@@ -12237,7 +12237,7 @@
                 <a:ea typeface="Palatino Linotype" pitchFamily="34" charset="-122"/>
                 <a:cs typeface="Palatino Linotype" pitchFamily="34" charset="-120"/>
               </a:rPr>
-              <a:t>Ce que nous avons changé après vos réponses</a:t>
+              <a:t>Ce que nous faisons de vos réponses</a:t>
             </a:r>
             <a:endParaRPr lang="en-US" sz="3200" dirty="0"/>
           </a:p>
@@ -12399,7 +12399,7 @@
                 <a:ea typeface="Palatino Linotype" pitchFamily="34" charset="-122"/>
                 <a:cs typeface="Palatino Linotype" pitchFamily="34" charset="-120"/>
               </a:rPr>
-              <a:t>À compléter après l’analyse des réponses du premier cours.</a:t>
+              <a:t>Nous lisons toutes les réponses au billet de sortie du premier cours.</a:t>
             </a:r>
             <a:endParaRPr lang="en-US" sz="1800" dirty="0"/>
           </a:p>
@@ -12561,7 +12561,7 @@
                 <a:ea typeface="Palatino Linotype" pitchFamily="34" charset="-122"/>
                 <a:cs typeface="Palatino Linotype" pitchFamily="34" charset="-120"/>
               </a:rPr>
-              <a:t>À compléter après l’analyse des réponses du premier cours.</a:t>
+              <a:t>Nous retenons deux modifications et nous les appliquons dès le cours suivant.</a:t>
             </a:r>
             <a:endParaRPr lang="en-US" sz="1800" dirty="0"/>
           </a:p>
@@ -12600,7 +12600,7 @@
                 <a:ea typeface="Palatino Linotype" pitchFamily="34" charset="-122"/>
                 <a:cs typeface="Palatino Linotype" pitchFamily="34" charset="-120"/>
               </a:rPr>
-              <a:t>Les deux mêmes modifications figurent aussi sur la page de la discipline.</a:t>
+              <a:t>Les deux modifications figureront aussi sur la page de la discipline.</a:t>
             </a:r>
             <a:endParaRPr lang="en-US" sz="1600" dirty="0"/>
           </a:p>

</xml_diff>